<commit_message>
feat: add lesson 10 LangChain chunking and materials
</commit_message>
<xml_diff>
--- a/docs/作业提交/第09课_AI出题与智能测评/第09课_AI出题与智能测评_学习总结.pptx
+++ b/docs/作业提交/第09课_AI出题与智能测评/第09课_AI出题与智能测评_学习总结.pptx
@@ -13,14 +13,105 @@
     <p:sldId id="261" r:id="rId7"/>
     <p:sldId id="262" r:id="rId8"/>
     <p:sldId id="263" r:id="rId9"/>
-    <p:sldId id="264" r:id="rId10"/>
-    <p:sldId id="265" r:id="rId11"/>
-    <p:sldId id="266" r:id="rId12"/>
-    <p:sldId id="267" r:id="rId13"/>
-    <p:sldId id="268" r:id="rId14"/>
+    <p:sldId id="268" r:id="rId10"/>
   </p:sldIdLst>
   <p:sldSz cx="12192000" cy="6858000"/>
   <p:notesSz cx="6858000" cy="9144000"/>
+  <p:defaultTextStyle>
+    <a:defPPr>
+      <a:defRPr lang="zh-CN"/>
+    </a:defPPr>
+    <a:lvl1pPr marL="0" algn="l" defTabSz="914400" rtl="0" eaLnBrk="1" latinLnBrk="0" hangingPunct="1">
+      <a:defRPr sz="1800" kern="1200">
+        <a:solidFill>
+          <a:schemeClr val="tx1"/>
+        </a:solidFill>
+        <a:latin typeface="+mn-lt"/>
+        <a:ea typeface="+mn-ea"/>
+        <a:cs typeface="+mn-cs"/>
+      </a:defRPr>
+    </a:lvl1pPr>
+    <a:lvl2pPr marL="457200" algn="l" defTabSz="914400" rtl="0" eaLnBrk="1" latinLnBrk="0" hangingPunct="1">
+      <a:defRPr sz="1800" kern="1200">
+        <a:solidFill>
+          <a:schemeClr val="tx1"/>
+        </a:solidFill>
+        <a:latin typeface="+mn-lt"/>
+        <a:ea typeface="+mn-ea"/>
+        <a:cs typeface="+mn-cs"/>
+      </a:defRPr>
+    </a:lvl2pPr>
+    <a:lvl3pPr marL="914400" algn="l" defTabSz="914400" rtl="0" eaLnBrk="1" latinLnBrk="0" hangingPunct="1">
+      <a:defRPr sz="1800" kern="1200">
+        <a:solidFill>
+          <a:schemeClr val="tx1"/>
+        </a:solidFill>
+        <a:latin typeface="+mn-lt"/>
+        <a:ea typeface="+mn-ea"/>
+        <a:cs typeface="+mn-cs"/>
+      </a:defRPr>
+    </a:lvl3pPr>
+    <a:lvl4pPr marL="1371600" algn="l" defTabSz="914400" rtl="0" eaLnBrk="1" latinLnBrk="0" hangingPunct="1">
+      <a:defRPr sz="1800" kern="1200">
+        <a:solidFill>
+          <a:schemeClr val="tx1"/>
+        </a:solidFill>
+        <a:latin typeface="+mn-lt"/>
+        <a:ea typeface="+mn-ea"/>
+        <a:cs typeface="+mn-cs"/>
+      </a:defRPr>
+    </a:lvl4pPr>
+    <a:lvl5pPr marL="1828800" algn="l" defTabSz="914400" rtl="0" eaLnBrk="1" latinLnBrk="0" hangingPunct="1">
+      <a:defRPr sz="1800" kern="1200">
+        <a:solidFill>
+          <a:schemeClr val="tx1"/>
+        </a:solidFill>
+        <a:latin typeface="+mn-lt"/>
+        <a:ea typeface="+mn-ea"/>
+        <a:cs typeface="+mn-cs"/>
+      </a:defRPr>
+    </a:lvl5pPr>
+    <a:lvl6pPr marL="2286000" algn="l" defTabSz="914400" rtl="0" eaLnBrk="1" latinLnBrk="0" hangingPunct="1">
+      <a:defRPr sz="1800" kern="1200">
+        <a:solidFill>
+          <a:schemeClr val="tx1"/>
+        </a:solidFill>
+        <a:latin typeface="+mn-lt"/>
+        <a:ea typeface="+mn-ea"/>
+        <a:cs typeface="+mn-cs"/>
+      </a:defRPr>
+    </a:lvl6pPr>
+    <a:lvl7pPr marL="2743200" algn="l" defTabSz="914400" rtl="0" eaLnBrk="1" latinLnBrk="0" hangingPunct="1">
+      <a:defRPr sz="1800" kern="1200">
+        <a:solidFill>
+          <a:schemeClr val="tx1"/>
+        </a:solidFill>
+        <a:latin typeface="+mn-lt"/>
+        <a:ea typeface="+mn-ea"/>
+        <a:cs typeface="+mn-cs"/>
+      </a:defRPr>
+    </a:lvl7pPr>
+    <a:lvl8pPr marL="3200400" algn="l" defTabSz="914400" rtl="0" eaLnBrk="1" latinLnBrk="0" hangingPunct="1">
+      <a:defRPr sz="1800" kern="1200">
+        <a:solidFill>
+          <a:schemeClr val="tx1"/>
+        </a:solidFill>
+        <a:latin typeface="+mn-lt"/>
+        <a:ea typeface="+mn-ea"/>
+        <a:cs typeface="+mn-cs"/>
+      </a:defRPr>
+    </a:lvl8pPr>
+    <a:lvl9pPr marL="3657600" algn="l" defTabSz="914400" rtl="0" eaLnBrk="1" latinLnBrk="0" hangingPunct="1">
+      <a:defRPr sz="1800" kern="1200">
+        <a:solidFill>
+          <a:schemeClr val="tx1"/>
+        </a:solidFill>
+        <a:latin typeface="+mn-lt"/>
+        <a:ea typeface="+mn-ea"/>
+        <a:cs typeface="+mn-cs"/>
+      </a:defRPr>
+    </a:lvl9pPr>
+  </p:defaultTextStyle>
 </p:presentation>
 </file>
 
@@ -52,6 +143,11 @@
 <file path=ppt/slideMasters/slideMaster1.xml><?xml version="1.0" encoding="utf-8"?>
 <p:sldMaster xmlns:a="http://schemas.openxmlformats.org/drawingml/2006/main" xmlns:r="http://schemas.openxmlformats.org/officeDocument/2006/relationships" xmlns:p="http://schemas.openxmlformats.org/presentationml/2006/main">
   <p:cSld>
+    <p:bg>
+      <p:bgRef idx="1001">
+        <a:schemeClr val="bg1"/>
+      </p:bgRef>
+    </p:bg>
     <p:spTree>
       <p:nvGrpSpPr>
         <p:cNvPr id="1" name=""/>
@@ -127,7 +223,7 @@
           </a:prstGeom>
         </p:spPr>
         <p:txBody>
-          <a:bodyPr wrap="square" rtlCol="0" lIns="0" tIns="0" rIns="0" bIns="0" anchor="t">
+          <a:bodyPr wrap="square" lIns="0" tIns="0" rIns="0" bIns="0" rtlCol="0" anchor="t">
             <a:spAutoFit/>
           </a:bodyPr>
           <a:lstStyle/>
@@ -175,7 +271,7 @@
           </a:prstGeom>
         </p:spPr>
         <p:txBody>
-          <a:bodyPr wrap="square" rtlCol="0" lIns="0" tIns="0" rIns="0" bIns="0" anchor="t">
+          <a:bodyPr wrap="square" lIns="0" tIns="0" rIns="0" bIns="0" rtlCol="0" anchor="t">
             <a:spAutoFit/>
           </a:bodyPr>
           <a:lstStyle/>
@@ -223,7 +319,7 @@
           </a:prstGeom>
         </p:spPr>
         <p:txBody>
-          <a:bodyPr wrap="square" rtlCol="0" lIns="0" tIns="0" rIns="0" bIns="0" anchor="t">
+          <a:bodyPr wrap="square" lIns="0" tIns="0" rIns="0" bIns="0" rtlCol="0" anchor="t">
             <a:spAutoFit/>
           </a:bodyPr>
           <a:lstStyle/>
@@ -271,7 +367,7 @@
           </a:prstGeom>
         </p:spPr>
         <p:txBody>
-          <a:bodyPr wrap="square" rtlCol="0" lIns="0" tIns="0" rIns="0" bIns="0" anchor="t">
+          <a:bodyPr wrap="square" lIns="0" tIns="0" rIns="0" bIns="0" rtlCol="0" anchor="t">
             <a:spAutoFit/>
           </a:bodyPr>
           <a:lstStyle/>
@@ -341,7 +437,7 @@
           </a:prstGeom>
         </p:spPr>
         <p:txBody>
-          <a:bodyPr wrap="square" rtlCol="0" lIns="0" tIns="0" rIns="0" bIns="0" anchor="t">
+          <a:bodyPr wrap="square" lIns="0" tIns="0" rIns="0" bIns="0" rtlCol="0" anchor="t">
             <a:spAutoFit/>
           </a:bodyPr>
           <a:lstStyle/>
@@ -363,1344 +459,6 @@
                 <a:ea typeface="Hiragino Sans GB"/>
               </a:rPr>
               <a:t>01 / 13</a:t>
-            </a:r>
-          </a:p>
-        </p:txBody>
-      </p:sp>
-    </p:spTree>
-  </p:cSld>
-  <p:clrMapOvr>
-    <a:masterClrMapping/>
-  </p:clrMapOvr>
-</p:sld>
-</file>
-
-<file path=ppt/slides/slide10.xml><?xml version="1.0" encoding="utf-8"?>
-<p:sld xmlns:a="http://schemas.openxmlformats.org/drawingml/2006/main" xmlns:r="http://schemas.openxmlformats.org/officeDocument/2006/relationships" xmlns:p="http://schemas.openxmlformats.org/presentationml/2006/main">
-  <p:cSld>
-    <p:bg>
-      <p:bgPr>
-        <a:solidFill>
-          <a:srgbClr val="F6F5F0"/>
-        </a:solidFill>
-        <a:effectLst/>
-      </p:bgPr>
-    </p:bg>
-    <p:spTree>
-      <p:nvGrpSpPr>
-        <p:cNvPr id="1" name=""/>
-        <p:cNvGrpSpPr/>
-        <p:nvPr/>
-      </p:nvGrpSpPr>
-      <p:grpSpPr>
-        <a:xfrm>
-          <a:off x="0" y="0"/>
-          <a:ext cx="0" cy="0"/>
-          <a:chOff x="0" y="0"/>
-          <a:chExt cx="0" cy="0"/>
-        </a:xfrm>
-      </p:grpSpPr>
-      <p:sp>
-        <p:nvSpPr>
-          <p:cNvPr id="3" name="TextBox 3">
-            <a:extLst>
-              <a:ext uri="{FF2B5EF4-FFF2-40B4-BE49-F238E27FC236}">
-                <a16:creationId xmlns:a16="http://schemas.microsoft.com/office/drawing/2014/main" id="{837C34BC-ECF9-47C7-BC5D-EBAF78013BBB}"/>
-              </a:ext>
-            </a:extLst>
-          </p:cNvPr>
-          <p:cNvSpPr txBox="1"/>
-          <p:nvPr/>
-        </p:nvSpPr>
-        <p:spPr>
-          <a:xfrm>
-            <a:off x="666750" y="476250"/>
-            <a:ext cx="10858500" cy="857250"/>
-          </a:xfrm>
-          <a:prstGeom prst="rect">
-            <a:avLst/>
-          </a:prstGeom>
-        </p:spPr>
-        <p:txBody>
-          <a:bodyPr wrap="square" rtlCol="0" lIns="0" tIns="0" rIns="0" bIns="0" anchor="t">
-            <a:spAutoFit/>
-          </a:bodyPr>
-          <a:lstStyle/>
-          <a:p>
-            <a:pPr>
-              <a:lnSpc>
-                <a:spcPct val="115000"/>
-              </a:lnSpc>
-              <a:spcAft>
-                <a:spcPts val="0"/>
-              </a:spcAft>
-            </a:pPr>
-            <a:r>
-              <a:rPr sz="3400" b="1">
-                <a:solidFill>
-                  <a:srgbClr val="152B3C"/>
-                </a:solidFill>
-                <a:latin typeface="Hiragino Sans GB"/>
-                <a:ea typeface="Hiragino Sans GB"/>
-              </a:rPr>
-              <a:t>自测题：简答与情境题</a:t>
-            </a:r>
-          </a:p>
-        </p:txBody>
-      </p:sp>
-      <p:sp>
-        <p:nvSpPr>
-          <p:cNvPr id="4" name="TextBox 4">
-            <a:extLst>
-              <a:ext uri="{FF2B5EF4-FFF2-40B4-BE49-F238E27FC236}">
-                <a16:creationId xmlns:a16="http://schemas.microsoft.com/office/drawing/2014/main" id="{823EDD68-70D6-4E09-A6AA-92EA0E7CCB98}"/>
-              </a:ext>
-            </a:extLst>
-          </p:cNvPr>
-          <p:cNvSpPr txBox="1"/>
-          <p:nvPr/>
-        </p:nvSpPr>
-        <p:spPr>
-          <a:xfrm>
-            <a:off x="685800" y="1752600"/>
-            <a:ext cx="5095875" cy="514350"/>
-          </a:xfrm>
-          <a:prstGeom prst="rect">
-            <a:avLst/>
-          </a:prstGeom>
-        </p:spPr>
-        <p:txBody>
-          <a:bodyPr wrap="square" rtlCol="0" lIns="0" tIns="0" rIns="0" bIns="0" anchor="t">
-            <a:spAutoFit/>
-          </a:bodyPr>
-          <a:lstStyle/>
-          <a:p>
-            <a:pPr>
-              <a:lnSpc>
-                <a:spcPct val="115000"/>
-              </a:lnSpc>
-              <a:spcAft>
-                <a:spcPts val="0"/>
-              </a:spcAft>
-            </a:pPr>
-            <a:r>
-              <a:rPr sz="2500" b="1">
-                <a:solidFill>
-                  <a:srgbClr val="166A68"/>
-                </a:solidFill>
-                <a:latin typeface="Hiragino Sans GB"/>
-                <a:ea typeface="Hiragino Sans GB"/>
-              </a:rPr>
-              <a:t>05—06｜每题 20 分</a:t>
-            </a:r>
-          </a:p>
-        </p:txBody>
-      </p:sp>
-      <p:sp>
-        <p:nvSpPr>
-          <p:cNvPr id="5" name="TextBox 5">
-            <a:extLst>
-              <a:ext uri="{FF2B5EF4-FFF2-40B4-BE49-F238E27FC236}">
-                <a16:creationId xmlns:a16="http://schemas.microsoft.com/office/drawing/2014/main" id="{1AFC8F15-987E-433F-898F-68EFAD24DA86}"/>
-              </a:ext>
-            </a:extLst>
-          </p:cNvPr>
-          <p:cNvSpPr txBox="1"/>
-          <p:nvPr/>
-        </p:nvSpPr>
-        <p:spPr>
-          <a:xfrm>
-            <a:off x="685800" y="2524125"/>
-            <a:ext cx="5095875" cy="3286125"/>
-          </a:xfrm>
-          <a:prstGeom prst="rect">
-            <a:avLst/>
-          </a:prstGeom>
-        </p:spPr>
-        <p:txBody>
-          <a:bodyPr wrap="square" rtlCol="0" lIns="0" tIns="0" rIns="0" bIns="0" anchor="t">
-            <a:spAutoFit/>
-          </a:bodyPr>
-          <a:lstStyle/>
-          <a:p>
-            <a:pPr>
-              <a:lnSpc>
-                <a:spcPct val="115000"/>
-              </a:lnSpc>
-              <a:spcAft>
-                <a:spcPts val="0"/>
-              </a:spcAft>
-            </a:pPr>
-            <a:r>
-              <a:rPr sz="2100">
-                <a:solidFill>
-                  <a:srgbClr val="152B3C"/>
-                </a:solidFill>
-                <a:latin typeface="Hiragino Sans GB"/>
-                <a:ea typeface="Hiragino Sans GB"/>
-              </a:rPr>
-              <a:t>5. 设计“出题—作答—评分—复习”流程，</a:t>
-            </a:r>
-            <a:br/>
-            <a:r>
-              <a:rPr sz="2100">
-                <a:solidFill>
-                  <a:srgbClr val="152B3C"/>
-                </a:solidFill>
-                <a:latin typeface="Hiragino Sans GB"/>
-                <a:ea typeface="Hiragino Sans GB"/>
-              </a:rPr>
-              <a:t>说明前后端各自负责什么。</a:t>
-            </a:r>
-            <a:br/>
-            <a:br/>
-            <a:r>
-              <a:rPr sz="2100">
-                <a:solidFill>
-                  <a:srgbClr val="152B3C"/>
-                </a:solidFill>
-                <a:latin typeface="Hiragino Sans GB"/>
-                <a:ea typeface="Hiragino Sans GB"/>
-              </a:rPr>
-              <a:t>6. 模型返回的 JSON 可以解析，但缺少</a:t>
-            </a:r>
-            <a:br/>
-            <a:r>
-              <a:rPr sz="2100">
-                <a:solidFill>
-                  <a:srgbClr val="152B3C"/>
-                </a:solidFill>
-                <a:latin typeface="Hiragino Sans GB"/>
-                <a:ea typeface="Hiragino Sans GB"/>
-              </a:rPr>
-              <a:t> options 或答案不在选项内，应该如何</a:t>
-            </a:r>
-            <a:br/>
-            <a:r>
-              <a:rPr sz="2100">
-                <a:solidFill>
-                  <a:srgbClr val="152B3C"/>
-                </a:solidFill>
-                <a:latin typeface="Hiragino Sans GB"/>
-                <a:ea typeface="Hiragino Sans GB"/>
-              </a:rPr>
-              <a:t>处理？</a:t>
-            </a:r>
-          </a:p>
-        </p:txBody>
-      </p:sp>
-      <p:sp>
-        <p:nvSpPr>
-          <p:cNvPr id="6" name="TextBox 6">
-            <a:extLst>
-              <a:ext uri="{FF2B5EF4-FFF2-40B4-BE49-F238E27FC236}">
-                <a16:creationId xmlns:a16="http://schemas.microsoft.com/office/drawing/2014/main" id="{4048DA73-CA42-43BF-B406-4F5E4E0FF69E}"/>
-              </a:ext>
-            </a:extLst>
-          </p:cNvPr>
-          <p:cNvSpPr txBox="1"/>
-          <p:nvPr/>
-        </p:nvSpPr>
-        <p:spPr>
-          <a:xfrm>
-            <a:off x="6438900" y="1752600"/>
-            <a:ext cx="5095875" cy="514350"/>
-          </a:xfrm>
-          <a:prstGeom prst="rect">
-            <a:avLst/>
-          </a:prstGeom>
-        </p:spPr>
-        <p:txBody>
-          <a:bodyPr wrap="square" rtlCol="0" lIns="0" tIns="0" rIns="0" bIns="0" anchor="t">
-            <a:spAutoFit/>
-          </a:bodyPr>
-          <a:lstStyle/>
-          <a:p>
-            <a:pPr>
-              <a:lnSpc>
-                <a:spcPct val="115000"/>
-              </a:lnSpc>
-              <a:spcAft>
-                <a:spcPts val="0"/>
-              </a:spcAft>
-            </a:pPr>
-            <a:r>
-              <a:rPr sz="2500" b="1">
-                <a:solidFill>
-                  <a:srgbClr val="166A68"/>
-                </a:solidFill>
-                <a:latin typeface="Hiragino Sans GB"/>
-                <a:ea typeface="Hiragino Sans GB"/>
-              </a:rPr>
-              <a:t>07—08｜每题 20 分</a:t>
-            </a:r>
-          </a:p>
-        </p:txBody>
-      </p:sp>
-      <p:sp>
-        <p:nvSpPr>
-          <p:cNvPr id="7" name="TextBox 7">
-            <a:extLst>
-              <a:ext uri="{FF2B5EF4-FFF2-40B4-BE49-F238E27FC236}">
-                <a16:creationId xmlns:a16="http://schemas.microsoft.com/office/drawing/2014/main" id="{761205AD-206E-4871-8DFB-9DBC37742D04}"/>
-              </a:ext>
-            </a:extLst>
-          </p:cNvPr>
-          <p:cNvSpPr txBox="1"/>
-          <p:nvPr/>
-        </p:nvSpPr>
-        <p:spPr>
-          <a:xfrm>
-            <a:off x="6438900" y="2524125"/>
-            <a:ext cx="5095875" cy="3286125"/>
-          </a:xfrm>
-          <a:prstGeom prst="rect">
-            <a:avLst/>
-          </a:prstGeom>
-        </p:spPr>
-        <p:txBody>
-          <a:bodyPr wrap="square" rtlCol="0" lIns="0" tIns="0" rIns="0" bIns="0" anchor="t">
-            <a:spAutoFit/>
-          </a:bodyPr>
-          <a:lstStyle/>
-          <a:p>
-            <a:pPr>
-              <a:lnSpc>
-                <a:spcPct val="115000"/>
-              </a:lnSpc>
-              <a:spcAft>
-                <a:spcPts val="0"/>
-              </a:spcAft>
-            </a:pPr>
-            <a:r>
-              <a:rPr sz="2100">
-                <a:solidFill>
-                  <a:srgbClr val="152B3C"/>
-                </a:solidFill>
-                <a:latin typeface="Hiragino Sans GB"/>
-                <a:ea typeface="Hiragino Sans GB"/>
-              </a:rPr>
-              <a:t>7. 如何让 AI 公平地评价简答题？请说</a:t>
-            </a:r>
-            <a:br/>
-            <a:r>
-              <a:rPr sz="2100">
-                <a:solidFill>
-                  <a:srgbClr val="152B3C"/>
-                </a:solidFill>
-                <a:latin typeface="Hiragino Sans GB"/>
-                <a:ea typeface="Hiragino Sans GB"/>
-              </a:rPr>
-              <a:t>明评分输入、规则、输出及可信性。</a:t>
-            </a:r>
-            <a:br/>
-            <a:br/>
-            <a:r>
-              <a:rPr sz="2100">
-                <a:solidFill>
-                  <a:srgbClr val="152B3C"/>
-                </a:solidFill>
-                <a:latin typeface="Hiragino Sans GB"/>
-                <a:ea typeface="Hiragino Sans GB"/>
-              </a:rPr>
-              <a:t>8. 设计至少四个失败场景，说明页面如</a:t>
-            </a:r>
-            <a:br/>
-            <a:r>
-              <a:rPr sz="2100">
-                <a:solidFill>
-                  <a:srgbClr val="152B3C"/>
-                </a:solidFill>
-                <a:latin typeface="Hiragino Sans GB"/>
-                <a:ea typeface="Hiragino Sans GB"/>
-              </a:rPr>
-              <a:t>何处理，以及哪些状态需要保留或重置。</a:t>
-            </a:r>
-          </a:p>
-        </p:txBody>
-      </p:sp>
-      <p:sp>
-        <p:nvSpPr>
-          <p:cNvPr id="8" name="TextBox 8">
-            <a:extLst>
-              <a:ext uri="{FF2B5EF4-FFF2-40B4-BE49-F238E27FC236}">
-                <a16:creationId xmlns:a16="http://schemas.microsoft.com/office/drawing/2014/main" id="{CEA11A17-6B8C-4C30-B4E1-2F33FF72EBFB}"/>
-              </a:ext>
-            </a:extLst>
-          </p:cNvPr>
-          <p:cNvSpPr txBox="1"/>
-          <p:nvPr/>
-        </p:nvSpPr>
-        <p:spPr>
-          <a:xfrm>
-            <a:off x="10715625" y="6305550"/>
-            <a:ext cx="904875" cy="266700"/>
-          </a:xfrm>
-          <a:prstGeom prst="rect">
-            <a:avLst/>
-          </a:prstGeom>
-        </p:spPr>
-        <p:txBody>
-          <a:bodyPr wrap="square" rtlCol="0" lIns="0" tIns="0" rIns="0" bIns="0" anchor="t">
-            <a:spAutoFit/>
-          </a:bodyPr>
-          <a:lstStyle/>
-          <a:p>
-            <a:pPr>
-              <a:lnSpc>
-                <a:spcPct val="115000"/>
-              </a:lnSpc>
-              <a:spcAft>
-                <a:spcPts val="0"/>
-              </a:spcAft>
-            </a:pPr>
-            <a:r>
-              <a:rPr sz="1200">
-                <a:solidFill>
-                  <a:srgbClr val="667885"/>
-                </a:solidFill>
-                <a:latin typeface="Hiragino Sans GB"/>
-                <a:ea typeface="Hiragino Sans GB"/>
-              </a:rPr>
-              <a:t>10 / 13</a:t>
-            </a:r>
-          </a:p>
-        </p:txBody>
-      </p:sp>
-    </p:spTree>
-  </p:cSld>
-  <p:clrMapOvr>
-    <a:masterClrMapping/>
-  </p:clrMapOvr>
-</p:sld>
-</file>
-
-<file path=ppt/slides/slide11.xml><?xml version="1.0" encoding="utf-8"?>
-<p:sld xmlns:a="http://schemas.openxmlformats.org/drawingml/2006/main" xmlns:r="http://schemas.openxmlformats.org/officeDocument/2006/relationships" xmlns:p="http://schemas.openxmlformats.org/presentationml/2006/main">
-  <p:cSld>
-    <p:bg>
-      <p:bgPr>
-        <a:solidFill>
-          <a:srgbClr val="F6F5F0"/>
-        </a:solidFill>
-        <a:effectLst/>
-      </p:bgPr>
-    </p:bg>
-    <p:spTree>
-      <p:nvGrpSpPr>
-        <p:cNvPr id="1" name=""/>
-        <p:cNvGrpSpPr/>
-        <p:nvPr/>
-      </p:nvGrpSpPr>
-      <p:grpSpPr>
-        <a:xfrm>
-          <a:off x="0" y="0"/>
-          <a:ext cx="0" cy="0"/>
-          <a:chOff x="0" y="0"/>
-          <a:chExt cx="0" cy="0"/>
-        </a:xfrm>
-      </p:grpSpPr>
-      <p:sp>
-        <p:nvSpPr>
-          <p:cNvPr id="3" name="TextBox 3">
-            <a:extLst>
-              <a:ext uri="{FF2B5EF4-FFF2-40B4-BE49-F238E27FC236}">
-                <a16:creationId xmlns:a16="http://schemas.microsoft.com/office/drawing/2014/main" id="{47F3889C-9B90-426A-8B57-ABC4AD5DA8A1}"/>
-              </a:ext>
-            </a:extLst>
-          </p:cNvPr>
-          <p:cNvSpPr txBox="1"/>
-          <p:nvPr/>
-        </p:nvSpPr>
-        <p:spPr>
-          <a:xfrm>
-            <a:off x="666750" y="476250"/>
-            <a:ext cx="10858500" cy="857250"/>
-          </a:xfrm>
-          <a:prstGeom prst="rect">
-            <a:avLst/>
-          </a:prstGeom>
-        </p:spPr>
-        <p:txBody>
-          <a:bodyPr wrap="square" rtlCol="0" lIns="0" tIns="0" rIns="0" bIns="0" anchor="t">
-            <a:spAutoFit/>
-          </a:bodyPr>
-          <a:lstStyle/>
-          <a:p>
-            <a:pPr>
-              <a:lnSpc>
-                <a:spcPct val="115000"/>
-              </a:lnSpc>
-              <a:spcAft>
-                <a:spcPts val="0"/>
-              </a:spcAft>
-            </a:pPr>
-            <a:r>
-              <a:rPr sz="3400" b="1">
-                <a:solidFill>
-                  <a:srgbClr val="152B3C"/>
-                </a:solidFill>
-                <a:latin typeface="Hiragino Sans GB"/>
-                <a:ea typeface="Hiragino Sans GB"/>
-              </a:rPr>
-              <a:t>参考答案与评分要点</a:t>
-            </a:r>
-          </a:p>
-        </p:txBody>
-      </p:sp>
-      <p:sp>
-        <p:nvSpPr>
-          <p:cNvPr id="4" name="TextBox 4">
-            <a:extLst>
-              <a:ext uri="{FF2B5EF4-FFF2-40B4-BE49-F238E27FC236}">
-                <a16:creationId xmlns:a16="http://schemas.microsoft.com/office/drawing/2014/main" id="{64F34258-367D-4CF6-8B7E-84E9786B90B9}"/>
-              </a:ext>
-            </a:extLst>
-          </p:cNvPr>
-          <p:cNvSpPr txBox="1"/>
-          <p:nvPr/>
-        </p:nvSpPr>
-        <p:spPr>
-          <a:xfrm>
-            <a:off x="685800" y="1752600"/>
-            <a:ext cx="5095875" cy="514350"/>
-          </a:xfrm>
-          <a:prstGeom prst="rect">
-            <a:avLst/>
-          </a:prstGeom>
-        </p:spPr>
-        <p:txBody>
-          <a:bodyPr wrap="square" rtlCol="0" lIns="0" tIns="0" rIns="0" bIns="0" anchor="t">
-            <a:spAutoFit/>
-          </a:bodyPr>
-          <a:lstStyle/>
-          <a:p>
-            <a:pPr>
-              <a:lnSpc>
-                <a:spcPct val="115000"/>
-              </a:lnSpc>
-              <a:spcAft>
-                <a:spcPts val="0"/>
-              </a:spcAft>
-            </a:pPr>
-            <a:r>
-              <a:rPr sz="2500" b="1">
-                <a:solidFill>
-                  <a:srgbClr val="166A68"/>
-                </a:solidFill>
-                <a:latin typeface="Hiragino Sans GB"/>
-                <a:ea typeface="Hiragino Sans GB"/>
-              </a:rPr>
-              <a:t>单选题与流程题</a:t>
-            </a:r>
-          </a:p>
-        </p:txBody>
-      </p:sp>
-      <p:sp>
-        <p:nvSpPr>
-          <p:cNvPr id="5" name="TextBox 5">
-            <a:extLst>
-              <a:ext uri="{FF2B5EF4-FFF2-40B4-BE49-F238E27FC236}">
-                <a16:creationId xmlns:a16="http://schemas.microsoft.com/office/drawing/2014/main" id="{343FC895-065E-4320-852B-E23382A1132D}"/>
-              </a:ext>
-            </a:extLst>
-          </p:cNvPr>
-          <p:cNvSpPr txBox="1"/>
-          <p:nvPr/>
-        </p:nvSpPr>
-        <p:spPr>
-          <a:xfrm>
-            <a:off x="685800" y="2524125"/>
-            <a:ext cx="5095875" cy="3286125"/>
-          </a:xfrm>
-          <a:prstGeom prst="rect">
-            <a:avLst/>
-          </a:prstGeom>
-        </p:spPr>
-        <p:txBody>
-          <a:bodyPr wrap="square" rtlCol="0" lIns="0" tIns="0" rIns="0" bIns="0" anchor="t">
-            <a:spAutoFit/>
-          </a:bodyPr>
-          <a:lstStyle/>
-          <a:p>
-            <a:pPr>
-              <a:lnSpc>
-                <a:spcPct val="115000"/>
-              </a:lnSpc>
-              <a:spcAft>
-                <a:spcPts val="0"/>
-              </a:spcAft>
-            </a:pPr>
-            <a:r>
-              <a:rPr sz="2100">
-                <a:solidFill>
-                  <a:srgbClr val="152B3C"/>
-                </a:solidFill>
-                <a:latin typeface="Hiragino Sans GB"/>
-                <a:ea typeface="Hiragino Sans GB"/>
-              </a:rPr>
-              <a:t>单选答案：1-B、2-C、3-B、4-D。</a:t>
-            </a:r>
-            <a:br/>
-            <a:r>
-              <a:rPr sz="2100">
-                <a:solidFill>
-                  <a:srgbClr val="152B3C"/>
-                </a:solidFill>
-                <a:latin typeface="Hiragino Sans GB"/>
-                <a:ea typeface="Hiragino Sans GB"/>
-              </a:rPr>
-              <a:t>第5题：输入与范围、出题校验、答题提</a:t>
-            </a:r>
-            <a:br/>
-            <a:r>
-              <a:rPr sz="2100">
-                <a:solidFill>
-                  <a:srgbClr val="152B3C"/>
-                </a:solidFill>
-                <a:latin typeface="Hiragino Sans GB"/>
-                <a:ea typeface="Hiragino Sans GB"/>
-              </a:rPr>
-              <a:t>交、反馈与复习，各 5 分。</a:t>
-            </a:r>
-            <a:br/>
-            <a:r>
-              <a:rPr sz="2100">
-                <a:solidFill>
-                  <a:srgbClr val="152B3C"/>
-                </a:solidFill>
-                <a:latin typeface="Hiragino Sans GB"/>
-                <a:ea typeface="Hiragino Sans GB"/>
-              </a:rPr>
-              <a:t>第6题：字段校验、值域校验、失败处理</a:t>
-            </a:r>
-            <a:br/>
-            <a:r>
-              <a:rPr sz="2100">
-                <a:solidFill>
-                  <a:srgbClr val="152B3C"/>
-                </a:solidFill>
-                <a:latin typeface="Hiragino Sans GB"/>
-                <a:ea typeface="Hiragino Sans GB"/>
-              </a:rPr>
-              <a:t>、前端反馈，各 5 分。</a:t>
-            </a:r>
-          </a:p>
-        </p:txBody>
-      </p:sp>
-      <p:sp>
-        <p:nvSpPr>
-          <p:cNvPr id="6" name="TextBox 6">
-            <a:extLst>
-              <a:ext uri="{FF2B5EF4-FFF2-40B4-BE49-F238E27FC236}">
-                <a16:creationId xmlns:a16="http://schemas.microsoft.com/office/drawing/2014/main" id="{128CA549-6016-4357-8181-7D8B3F831690}"/>
-              </a:ext>
-            </a:extLst>
-          </p:cNvPr>
-          <p:cNvSpPr txBox="1"/>
-          <p:nvPr/>
-        </p:nvSpPr>
-        <p:spPr>
-          <a:xfrm>
-            <a:off x="6438900" y="1752600"/>
-            <a:ext cx="5095875" cy="514350"/>
-          </a:xfrm>
-          <a:prstGeom prst="rect">
-            <a:avLst/>
-          </a:prstGeom>
-        </p:spPr>
-        <p:txBody>
-          <a:bodyPr wrap="square" rtlCol="0" lIns="0" tIns="0" rIns="0" bIns="0" anchor="t">
-            <a:spAutoFit/>
-          </a:bodyPr>
-          <a:lstStyle/>
-          <a:p>
-            <a:pPr>
-              <a:lnSpc>
-                <a:spcPct val="115000"/>
-              </a:lnSpc>
-              <a:spcAft>
-                <a:spcPts val="0"/>
-              </a:spcAft>
-            </a:pPr>
-            <a:r>
-              <a:rPr sz="2500" b="1">
-                <a:solidFill>
-                  <a:srgbClr val="166A68"/>
-                </a:solidFill>
-                <a:latin typeface="Hiragino Sans GB"/>
-                <a:ea typeface="Hiragino Sans GB"/>
-              </a:rPr>
-              <a:t>评分题与异常题</a:t>
-            </a:r>
-          </a:p>
-        </p:txBody>
-      </p:sp>
-      <p:sp>
-        <p:nvSpPr>
-          <p:cNvPr id="7" name="TextBox 7">
-            <a:extLst>
-              <a:ext uri="{FF2B5EF4-FFF2-40B4-BE49-F238E27FC236}">
-                <a16:creationId xmlns:a16="http://schemas.microsoft.com/office/drawing/2014/main" id="{610ACA56-BC41-47F9-A0E6-58D64C91B6B9}"/>
-              </a:ext>
-            </a:extLst>
-          </p:cNvPr>
-          <p:cNvSpPr txBox="1"/>
-          <p:nvPr/>
-        </p:nvSpPr>
-        <p:spPr>
-          <a:xfrm>
-            <a:off x="6438900" y="2524125"/>
-            <a:ext cx="5095875" cy="3286125"/>
-          </a:xfrm>
-          <a:prstGeom prst="rect">
-            <a:avLst/>
-          </a:prstGeom>
-        </p:spPr>
-        <p:txBody>
-          <a:bodyPr wrap="square" rtlCol="0" lIns="0" tIns="0" rIns="0" bIns="0" anchor="t">
-            <a:spAutoFit/>
-          </a:bodyPr>
-          <a:lstStyle/>
-          <a:p>
-            <a:pPr>
-              <a:lnSpc>
-                <a:spcPct val="115000"/>
-              </a:lnSpc>
-              <a:spcAft>
-                <a:spcPts val="0"/>
-              </a:spcAft>
-            </a:pPr>
-            <a:r>
-              <a:rPr sz="2100">
-                <a:solidFill>
-                  <a:srgbClr val="152B3C"/>
-                </a:solidFill>
-                <a:latin typeface="Hiragino Sans GB"/>
-                <a:ea typeface="Hiragino Sans GB"/>
-              </a:rPr>
-              <a:t>第7题：评分依据、语义与部分得分、结</a:t>
-            </a:r>
-            <a:br/>
-            <a:r>
-              <a:rPr sz="2100">
-                <a:solidFill>
-                  <a:srgbClr val="152B3C"/>
-                </a:solidFill>
-                <a:latin typeface="Hiragino Sans GB"/>
-                <a:ea typeface="Hiragino Sans GB"/>
-              </a:rPr>
-              <a:t>构化输出、可信性与复核，各 5 分。</a:t>
-            </a:r>
-            <a:br/>
-            <a:r>
-              <a:rPr sz="2100">
-                <a:solidFill>
-                  <a:srgbClr val="152B3C"/>
-                </a:solidFill>
-                <a:latin typeface="Hiragino Sans GB"/>
-                <a:ea typeface="Hiragino Sans GB"/>
-              </a:rPr>
-              <a:t>第8题：未作答、出题失败、评分失败、</a:t>
-            </a:r>
-            <a:br/>
-            <a:r>
-              <a:rPr sz="2100">
-                <a:solidFill>
-                  <a:srgbClr val="152B3C"/>
-                </a:solidFill>
-                <a:latin typeface="Hiragino Sans GB"/>
-                <a:ea typeface="Hiragino Sans GB"/>
-              </a:rPr>
-              <a:t>复习写入失败，各 5 分。</a:t>
-            </a:r>
-            <a:br/>
-            <a:r>
-              <a:rPr sz="2100">
-                <a:solidFill>
-                  <a:srgbClr val="152B3C"/>
-                </a:solidFill>
-                <a:latin typeface="Hiragino Sans GB"/>
-                <a:ea typeface="Hiragino Sans GB"/>
-              </a:rPr>
-              <a:t>每个场景需给出处理方式和状态变化。</a:t>
-            </a:r>
-          </a:p>
-        </p:txBody>
-      </p:sp>
-      <p:sp>
-        <p:nvSpPr>
-          <p:cNvPr id="8" name="TextBox 8">
-            <a:extLst>
-              <a:ext uri="{FF2B5EF4-FFF2-40B4-BE49-F238E27FC236}">
-                <a16:creationId xmlns:a16="http://schemas.microsoft.com/office/drawing/2014/main" id="{AA30BB1D-7926-42CE-9976-F245A21431FC}"/>
-              </a:ext>
-            </a:extLst>
-          </p:cNvPr>
-          <p:cNvSpPr txBox="1"/>
-          <p:nvPr/>
-        </p:nvSpPr>
-        <p:spPr>
-          <a:xfrm>
-            <a:off x="10715625" y="6305550"/>
-            <a:ext cx="904875" cy="266700"/>
-          </a:xfrm>
-          <a:prstGeom prst="rect">
-            <a:avLst/>
-          </a:prstGeom>
-        </p:spPr>
-        <p:txBody>
-          <a:bodyPr wrap="square" rtlCol="0" lIns="0" tIns="0" rIns="0" bIns="0" anchor="t">
-            <a:spAutoFit/>
-          </a:bodyPr>
-          <a:lstStyle/>
-          <a:p>
-            <a:pPr>
-              <a:lnSpc>
-                <a:spcPct val="115000"/>
-              </a:lnSpc>
-              <a:spcAft>
-                <a:spcPts val="0"/>
-              </a:spcAft>
-            </a:pPr>
-            <a:r>
-              <a:rPr sz="1200">
-                <a:solidFill>
-                  <a:srgbClr val="667885"/>
-                </a:solidFill>
-                <a:latin typeface="Hiragino Sans GB"/>
-                <a:ea typeface="Hiragino Sans GB"/>
-              </a:rPr>
-              <a:t>11 / 13</a:t>
-            </a:r>
-          </a:p>
-        </p:txBody>
-      </p:sp>
-    </p:spTree>
-  </p:cSld>
-  <p:clrMapOvr>
-    <a:masterClrMapping/>
-  </p:clrMapOvr>
-</p:sld>
-</file>
-
-<file path=ppt/slides/slide12.xml><?xml version="1.0" encoding="utf-8"?>
-<p:sld xmlns:a="http://schemas.openxmlformats.org/drawingml/2006/main" xmlns:r="http://schemas.openxmlformats.org/officeDocument/2006/relationships" xmlns:p="http://schemas.openxmlformats.org/presentationml/2006/main">
-  <p:cSld>
-    <p:bg>
-      <p:bgPr>
-        <a:solidFill>
-          <a:srgbClr val="F6F5F0"/>
-        </a:solidFill>
-        <a:effectLst/>
-      </p:bgPr>
-    </p:bg>
-    <p:spTree>
-      <p:nvGrpSpPr>
-        <p:cNvPr id="1" name=""/>
-        <p:cNvGrpSpPr/>
-        <p:nvPr/>
-      </p:nvGrpSpPr>
-      <p:grpSpPr>
-        <a:xfrm>
-          <a:off x="0" y="0"/>
-          <a:ext cx="0" cy="0"/>
-          <a:chOff x="0" y="0"/>
-          <a:chExt cx="0" cy="0"/>
-        </a:xfrm>
-      </p:grpSpPr>
-      <p:sp>
-        <p:nvSpPr>
-          <p:cNvPr id="3" name="TextBox 3">
-            <a:extLst>
-              <a:ext uri="{FF2B5EF4-FFF2-40B4-BE49-F238E27FC236}">
-                <a16:creationId xmlns:a16="http://schemas.microsoft.com/office/drawing/2014/main" id="{A0DB8A23-A376-49FC-A158-12D901DAAAAD}"/>
-              </a:ext>
-            </a:extLst>
-          </p:cNvPr>
-          <p:cNvSpPr txBox="1"/>
-          <p:nvPr/>
-        </p:nvSpPr>
-        <p:spPr>
-          <a:xfrm>
-            <a:off x="666750" y="476250"/>
-            <a:ext cx="10858500" cy="857250"/>
-          </a:xfrm>
-          <a:prstGeom prst="rect">
-            <a:avLst/>
-          </a:prstGeom>
-        </p:spPr>
-        <p:txBody>
-          <a:bodyPr wrap="square" rtlCol="0" lIns="0" tIns="0" rIns="0" bIns="0" anchor="t">
-            <a:spAutoFit/>
-          </a:bodyPr>
-          <a:lstStyle/>
-          <a:p>
-            <a:pPr>
-              <a:lnSpc>
-                <a:spcPct val="115000"/>
-              </a:lnSpc>
-              <a:spcAft>
-                <a:spcPts val="0"/>
-              </a:spcAft>
-            </a:pPr>
-            <a:r>
-              <a:rPr sz="3400" b="1">
-                <a:solidFill>
-                  <a:srgbClr val="152B3C"/>
-                </a:solidFill>
-                <a:latin typeface="Hiragino Sans GB"/>
-                <a:ea typeface="Hiragino Sans GB"/>
-              </a:rPr>
-              <a:t>AI 评分示例：86 / 100</a:t>
-            </a:r>
-          </a:p>
-        </p:txBody>
-      </p:sp>
-      <p:sp>
-        <p:nvSpPr>
-          <p:cNvPr id="4" name="TextBox 4">
-            <a:extLst>
-              <a:ext uri="{FF2B5EF4-FFF2-40B4-BE49-F238E27FC236}">
-                <a16:creationId xmlns:a16="http://schemas.microsoft.com/office/drawing/2014/main" id="{A54DA8A6-01D6-42E4-A2FF-EE05283DFD0F}"/>
-              </a:ext>
-            </a:extLst>
-          </p:cNvPr>
-          <p:cNvSpPr txBox="1"/>
-          <p:nvPr/>
-        </p:nvSpPr>
-        <p:spPr>
-          <a:xfrm>
-            <a:off x="685800" y="1714500"/>
-            <a:ext cx="10668000" cy="714375"/>
-          </a:xfrm>
-          <a:prstGeom prst="rect">
-            <a:avLst/>
-          </a:prstGeom>
-        </p:spPr>
-        <p:txBody>
-          <a:bodyPr wrap="square" rtlCol="0" lIns="0" tIns="0" rIns="0" bIns="0" anchor="t">
-            <a:spAutoFit/>
-          </a:bodyPr>
-          <a:lstStyle/>
-          <a:p>
-            <a:pPr>
-              <a:lnSpc>
-                <a:spcPct val="115000"/>
-              </a:lnSpc>
-              <a:spcAft>
-                <a:spcPts val="0"/>
-              </a:spcAft>
-            </a:pPr>
-            <a:r>
-              <a:rPr sz="2700" b="1">
-                <a:solidFill>
-                  <a:srgbClr val="166A68"/>
-                </a:solidFill>
-                <a:latin typeface="Hiragino Sans GB"/>
-                <a:ea typeface="Hiragino Sans GB"/>
-              </a:rPr>
-              <a:t>模拟答卷，不代表本人实测成绩</a:t>
-            </a:r>
-          </a:p>
-        </p:txBody>
-      </p:sp>
-      <p:sp>
-        <p:nvSpPr>
-          <p:cNvPr id="5" name="TextBox 5">
-            <a:extLst>
-              <a:ext uri="{FF2B5EF4-FFF2-40B4-BE49-F238E27FC236}">
-                <a16:creationId xmlns:a16="http://schemas.microsoft.com/office/drawing/2014/main" id="{B1070C8C-31FE-4AED-A8FA-65BC18710295}"/>
-              </a:ext>
-            </a:extLst>
-          </p:cNvPr>
-          <p:cNvSpPr txBox="1"/>
-          <p:nvPr/>
-        </p:nvSpPr>
-        <p:spPr>
-          <a:xfrm>
-            <a:off x="685800" y="2714625"/>
-            <a:ext cx="10668000" cy="3095625"/>
-          </a:xfrm>
-          <a:prstGeom prst="rect">
-            <a:avLst/>
-          </a:prstGeom>
-        </p:spPr>
-        <p:txBody>
-          <a:bodyPr wrap="square" rtlCol="0" lIns="0" tIns="0" rIns="0" bIns="0" anchor="t">
-            <a:spAutoFit/>
-          </a:bodyPr>
-          <a:lstStyle/>
-          <a:p>
-            <a:pPr>
-              <a:lnSpc>
-                <a:spcPct val="115000"/>
-              </a:lnSpc>
-              <a:spcAft>
-                <a:spcPts val="0"/>
-              </a:spcAft>
-            </a:pPr>
-            <a:r>
-              <a:rPr sz="2300">
-                <a:solidFill>
-                  <a:srgbClr val="152B3C"/>
-                </a:solidFill>
-                <a:latin typeface="Hiragino Sans GB"/>
-                <a:ea typeface="Hiragino Sans GB"/>
-              </a:rPr>
-              <a:t>单选题 20/20　流程设计 18/20</a:t>
-            </a:r>
-            <a:br/>
-            <a:r>
-              <a:rPr sz="2300">
-                <a:solidFill>
-                  <a:srgbClr val="152B3C"/>
-                </a:solidFill>
-                <a:latin typeface="Hiragino Sans GB"/>
-                <a:ea typeface="Hiragino Sans GB"/>
-              </a:rPr>
-              <a:t>数据校验 16/20　评分设计 17/20</a:t>
-            </a:r>
-            <a:br/>
-            <a:r>
-              <a:rPr sz="2300">
-                <a:solidFill>
-                  <a:srgbClr val="152B3C"/>
-                </a:solidFill>
-                <a:latin typeface="Hiragino Sans GB"/>
-                <a:ea typeface="Hiragino Sans GB"/>
-              </a:rPr>
-              <a:t>异常处理 15/20</a:t>
-            </a:r>
-            <a:br/>
-            <a:br/>
-            <a:r>
-              <a:rPr sz="2300">
-                <a:solidFill>
-                  <a:srgbClr val="152B3C"/>
-                </a:solidFill>
-                <a:latin typeface="Hiragino Sans GB"/>
-                <a:ea typeface="Hiragino Sans GB"/>
-              </a:rPr>
-              <a:t>主要扣分：未说明超时重试边界、模型评分复核与复习保存失败处理。</a:t>
-            </a:r>
-            <a:br/>
-            <a:r>
-              <a:rPr sz="2300">
-                <a:solidFill>
-                  <a:srgbClr val="152B3C"/>
-                </a:solidFill>
-                <a:latin typeface="Hiragino Sans GB"/>
-                <a:ea typeface="Hiragino Sans GB"/>
-              </a:rPr>
-              <a:t>完整模拟回答、逐项得分及改进建议见随附自测文件。</a:t>
-            </a:r>
-          </a:p>
-        </p:txBody>
-      </p:sp>
-      <p:sp>
-        <p:nvSpPr>
-          <p:cNvPr id="6" name="TextBox 6">
-            <a:extLst>
-              <a:ext uri="{FF2B5EF4-FFF2-40B4-BE49-F238E27FC236}">
-                <a16:creationId xmlns:a16="http://schemas.microsoft.com/office/drawing/2014/main" id="{D844E11B-F8E4-4827-9ED7-9D06AE5856D1}"/>
-              </a:ext>
-            </a:extLst>
-          </p:cNvPr>
-          <p:cNvSpPr txBox="1"/>
-          <p:nvPr/>
-        </p:nvSpPr>
-        <p:spPr>
-          <a:xfrm>
-            <a:off x="10715625" y="6305550"/>
-            <a:ext cx="904875" cy="266700"/>
-          </a:xfrm>
-          <a:prstGeom prst="rect">
-            <a:avLst/>
-          </a:prstGeom>
-        </p:spPr>
-        <p:txBody>
-          <a:bodyPr wrap="square" rtlCol="0" lIns="0" tIns="0" rIns="0" bIns="0" anchor="t">
-            <a:spAutoFit/>
-          </a:bodyPr>
-          <a:lstStyle/>
-          <a:p>
-            <a:pPr>
-              <a:lnSpc>
-                <a:spcPct val="115000"/>
-              </a:lnSpc>
-              <a:spcAft>
-                <a:spcPts val="0"/>
-              </a:spcAft>
-            </a:pPr>
-            <a:r>
-              <a:rPr sz="1200">
-                <a:solidFill>
-                  <a:srgbClr val="667885"/>
-                </a:solidFill>
-                <a:latin typeface="Hiragino Sans GB"/>
-                <a:ea typeface="Hiragino Sans GB"/>
-              </a:rPr>
-              <a:t>12 / 13</a:t>
-            </a:r>
-          </a:p>
-        </p:txBody>
-      </p:sp>
-    </p:spTree>
-  </p:cSld>
-  <p:clrMapOvr>
-    <a:masterClrMapping/>
-  </p:clrMapOvr>
-</p:sld>
-</file>
-
-<file path=ppt/slides/slide13.xml><?xml version="1.0" encoding="utf-8"?>
-<p:sld xmlns:a="http://schemas.openxmlformats.org/drawingml/2006/main" xmlns:r="http://schemas.openxmlformats.org/officeDocument/2006/relationships" xmlns:p="http://schemas.openxmlformats.org/presentationml/2006/main">
-  <p:cSld>
-    <p:bg>
-      <p:bgPr>
-        <a:solidFill>
-          <a:srgbClr val="152B3C"/>
-        </a:solidFill>
-        <a:effectLst/>
-      </p:bgPr>
-    </p:bg>
-    <p:spTree>
-      <p:nvGrpSpPr>
-        <p:cNvPr id="1" name=""/>
-        <p:cNvGrpSpPr/>
-        <p:nvPr/>
-      </p:nvGrpSpPr>
-      <p:grpSpPr>
-        <a:xfrm>
-          <a:off x="0" y="0"/>
-          <a:ext cx="0" cy="0"/>
-          <a:chOff x="0" y="0"/>
-          <a:chExt cx="0" cy="0"/>
-        </a:xfrm>
-      </p:grpSpPr>
-      <p:sp>
-        <p:nvSpPr>
-          <p:cNvPr id="3" name="TextBox 3">
-            <a:extLst>
-              <a:ext uri="{FF2B5EF4-FFF2-40B4-BE49-F238E27FC236}">
-                <a16:creationId xmlns:a16="http://schemas.microsoft.com/office/drawing/2014/main" id="{2999EDD3-0B8A-40E9-A1BD-83F15AFEB2F0}"/>
-              </a:ext>
-            </a:extLst>
-          </p:cNvPr>
-          <p:cNvSpPr txBox="1"/>
-          <p:nvPr/>
-        </p:nvSpPr>
-        <p:spPr>
-          <a:xfrm>
-            <a:off x="666750" y="476250"/>
-            <a:ext cx="10858500" cy="857250"/>
-          </a:xfrm>
-          <a:prstGeom prst="rect">
-            <a:avLst/>
-          </a:prstGeom>
-        </p:spPr>
-        <p:txBody>
-          <a:bodyPr wrap="square" rtlCol="0" lIns="0" tIns="0" rIns="0" bIns="0" anchor="t">
-            <a:spAutoFit/>
-          </a:bodyPr>
-          <a:lstStyle/>
-          <a:p>
-            <a:pPr>
-              <a:lnSpc>
-                <a:spcPct val="115000"/>
-              </a:lnSpc>
-              <a:spcAft>
-                <a:spcPts val="0"/>
-              </a:spcAft>
-            </a:pPr>
-            <a:r>
-              <a:rPr sz="3400" b="1">
-                <a:solidFill>
-                  <a:srgbClr val="F6F5F0"/>
-                </a:solidFill>
-                <a:latin typeface="Hiragino Sans GB"/>
-                <a:ea typeface="Hiragino Sans GB"/>
-              </a:rPr>
-              <a:t>第九课完成情景总结</a:t>
-            </a:r>
-          </a:p>
-        </p:txBody>
-      </p:sp>
-      <p:sp>
-        <p:nvSpPr>
-          <p:cNvPr id="4" name="TextBox 4">
-            <a:extLst>
-              <a:ext uri="{FF2B5EF4-FFF2-40B4-BE49-F238E27FC236}">
-                <a16:creationId xmlns:a16="http://schemas.microsoft.com/office/drawing/2014/main" id="{95CA5D89-313D-4A90-B08E-377997E37366}"/>
-              </a:ext>
-            </a:extLst>
-          </p:cNvPr>
-          <p:cNvSpPr txBox="1"/>
-          <p:nvPr/>
-        </p:nvSpPr>
-        <p:spPr>
-          <a:xfrm>
-            <a:off x="685800" y="1714500"/>
-            <a:ext cx="10668000" cy="714375"/>
-          </a:xfrm>
-          <a:prstGeom prst="rect">
-            <a:avLst/>
-          </a:prstGeom>
-        </p:spPr>
-        <p:txBody>
-          <a:bodyPr wrap="square" rtlCol="0" lIns="0" tIns="0" rIns="0" bIns="0" anchor="t">
-            <a:spAutoFit/>
-          </a:bodyPr>
-          <a:lstStyle/>
-          <a:p>
-            <a:pPr>
-              <a:lnSpc>
-                <a:spcPct val="115000"/>
-              </a:lnSpc>
-              <a:spcAft>
-                <a:spcPts val="0"/>
-              </a:spcAft>
-            </a:pPr>
-            <a:r>
-              <a:rPr sz="2700" b="1">
-                <a:solidFill>
-                  <a:srgbClr val="F6F5F0"/>
-                </a:solidFill>
-                <a:latin typeface="Hiragino Sans GB"/>
-                <a:ea typeface="Hiragino Sans GB"/>
-              </a:rPr>
-              <a:t>已完成设定</a:t>
-            </a:r>
-          </a:p>
-        </p:txBody>
-      </p:sp>
-      <p:sp>
-        <p:nvSpPr>
-          <p:cNvPr id="5" name="TextBox 5">
-            <a:extLst>
-              <a:ext uri="{FF2B5EF4-FFF2-40B4-BE49-F238E27FC236}">
-                <a16:creationId xmlns:a16="http://schemas.microsoft.com/office/drawing/2014/main" id="{4F120496-3109-4A1F-A844-0915DC4D1BE7}"/>
-              </a:ext>
-            </a:extLst>
-          </p:cNvPr>
-          <p:cNvSpPr txBox="1"/>
-          <p:nvPr/>
-        </p:nvSpPr>
-        <p:spPr>
-          <a:xfrm>
-            <a:off x="685800" y="2714625"/>
-            <a:ext cx="10668000" cy="3095625"/>
-          </a:xfrm>
-          <a:prstGeom prst="rect">
-            <a:avLst/>
-          </a:prstGeom>
-        </p:spPr>
-        <p:txBody>
-          <a:bodyPr wrap="square" rtlCol="0" lIns="0" tIns="0" rIns="0" bIns="0" anchor="t">
-            <a:spAutoFit/>
-          </a:bodyPr>
-          <a:lstStyle/>
-          <a:p>
-            <a:pPr>
-              <a:lnSpc>
-                <a:spcPct val="115000"/>
-              </a:lnSpc>
-              <a:spcAft>
-                <a:spcPts val="0"/>
-              </a:spcAft>
-            </a:pPr>
-            <a:r>
-              <a:rPr sz="2300">
-                <a:solidFill>
-                  <a:srgbClr val="F6F5F0"/>
-                </a:solidFill>
-                <a:latin typeface="Hiragino Sans GB"/>
-                <a:ea typeface="Hiragino Sans GB"/>
-              </a:rPr>
-              <a:t>基础流程：选择难度、生成单选题、作答判分、错题复习。</a:t>
-            </a:r>
-            <a:br/>
-            <a:r>
-              <a:rPr sz="2300">
-                <a:solidFill>
-                  <a:srgbClr val="F6F5F0"/>
-                </a:solidFill>
-                <a:latin typeface="Hiragino Sans GB"/>
-                <a:ea typeface="Hiragino Sans GB"/>
-              </a:rPr>
-              <a:t>挑战流程：简答题生成、按答案要点评分、展示解释。</a:t>
-            </a:r>
-            <a:br/>
-            <a:br/>
-            <a:r>
-              <a:rPr sz="2300">
-                <a:solidFill>
-                  <a:srgbClr val="F6F5F0"/>
-                </a:solidFill>
-                <a:latin typeface="Hiragino Sans GB"/>
-                <a:ea typeface="Hiragino Sans GB"/>
-              </a:rPr>
-              <a:t>下一步自测：独立回答 8 题，再按同一量表复评。</a:t>
-            </a:r>
-            <a:br/>
-            <a:r>
-              <a:rPr sz="2300">
-                <a:solidFill>
-                  <a:srgbClr val="F6F5F0"/>
-                </a:solidFill>
-                <a:latin typeface="Hiragino Sans GB"/>
-                <a:ea typeface="Hiragino Sans GB"/>
-              </a:rPr>
-              <a:t>课程材料中的功能描述为假设完成状态，不作为实际实现或验收证明。</a:t>
-            </a:r>
-          </a:p>
-        </p:txBody>
-      </p:sp>
-      <p:sp>
-        <p:nvSpPr>
-          <p:cNvPr id="6" name="TextBox 6">
-            <a:extLst>
-              <a:ext uri="{FF2B5EF4-FFF2-40B4-BE49-F238E27FC236}">
-                <a16:creationId xmlns:a16="http://schemas.microsoft.com/office/drawing/2014/main" id="{03A03BA2-470F-40DD-9FD0-E983EB1797E9}"/>
-              </a:ext>
-            </a:extLst>
-          </p:cNvPr>
-          <p:cNvSpPr txBox="1"/>
-          <p:nvPr/>
-        </p:nvSpPr>
-        <p:spPr>
-          <a:xfrm>
-            <a:off x="10715625" y="6305550"/>
-            <a:ext cx="904875" cy="266700"/>
-          </a:xfrm>
-          <a:prstGeom prst="rect">
-            <a:avLst/>
-          </a:prstGeom>
-        </p:spPr>
-        <p:txBody>
-          <a:bodyPr wrap="square" rtlCol="0" lIns="0" tIns="0" rIns="0" bIns="0" anchor="t">
-            <a:spAutoFit/>
-          </a:bodyPr>
-          <a:lstStyle/>
-          <a:p>
-            <a:pPr>
-              <a:lnSpc>
-                <a:spcPct val="115000"/>
-              </a:lnSpc>
-              <a:spcAft>
-                <a:spcPts val="0"/>
-              </a:spcAft>
-            </a:pPr>
-            <a:r>
-              <a:rPr sz="1200">
-                <a:solidFill>
-                  <a:srgbClr val="F6F5F0"/>
-                </a:solidFill>
-                <a:latin typeface="Hiragino Sans GB"/>
-                <a:ea typeface="Hiragino Sans GB"/>
-              </a:rPr>
-              <a:t>13 / 13</a:t>
             </a:r>
           </a:p>
         </p:txBody>
@@ -1760,7 +518,7 @@
           </a:prstGeom>
         </p:spPr>
         <p:txBody>
-          <a:bodyPr wrap="square" rtlCol="0" lIns="0" tIns="0" rIns="0" bIns="0" anchor="t">
+          <a:bodyPr wrap="square" lIns="0" tIns="0" rIns="0" bIns="0" rtlCol="0" anchor="t">
             <a:spAutoFit/>
           </a:bodyPr>
           <a:lstStyle/>
@@ -1808,7 +566,7 @@
           </a:prstGeom>
         </p:spPr>
         <p:txBody>
-          <a:bodyPr wrap="square" rtlCol="0" lIns="0" tIns="0" rIns="0" bIns="0" anchor="t">
+          <a:bodyPr wrap="square" lIns="0" tIns="0" rIns="0" bIns="0" rtlCol="0" anchor="t">
             <a:spAutoFit/>
           </a:bodyPr>
           <a:lstStyle/>
@@ -1856,7 +614,7 @@
           </a:prstGeom>
         </p:spPr>
         <p:txBody>
-          <a:bodyPr wrap="square" rtlCol="0" lIns="0" tIns="0" rIns="0" bIns="0" anchor="t">
+          <a:bodyPr wrap="square" lIns="0" tIns="0" rIns="0" bIns="0" rtlCol="0" anchor="t">
             <a:spAutoFit/>
           </a:bodyPr>
           <a:lstStyle/>
@@ -1926,7 +684,7 @@
           </a:prstGeom>
         </p:spPr>
         <p:txBody>
-          <a:bodyPr wrap="square" rtlCol="0" lIns="0" tIns="0" rIns="0" bIns="0" anchor="t">
+          <a:bodyPr wrap="square" lIns="0" tIns="0" rIns="0" bIns="0" rtlCol="0" anchor="t">
             <a:spAutoFit/>
           </a:bodyPr>
           <a:lstStyle/>
@@ -2007,7 +765,7 @@
           </a:prstGeom>
         </p:spPr>
         <p:txBody>
-          <a:bodyPr wrap="square" rtlCol="0" lIns="0" tIns="0" rIns="0" bIns="0" anchor="t">
+          <a:bodyPr wrap="square" lIns="0" tIns="0" rIns="0" bIns="0" rtlCol="0" anchor="t">
             <a:spAutoFit/>
           </a:bodyPr>
           <a:lstStyle/>
@@ -2055,7 +813,7 @@
           </a:prstGeom>
         </p:spPr>
         <p:txBody>
-          <a:bodyPr wrap="square" rtlCol="0" lIns="0" tIns="0" rIns="0" bIns="0" anchor="t">
+          <a:bodyPr wrap="square" lIns="0" tIns="0" rIns="0" bIns="0" rtlCol="0" anchor="t">
             <a:spAutoFit/>
           </a:bodyPr>
           <a:lstStyle/>
@@ -2103,7 +861,7 @@
           </a:prstGeom>
         </p:spPr>
         <p:txBody>
-          <a:bodyPr wrap="square" rtlCol="0" lIns="0" tIns="0" rIns="0" bIns="0" anchor="t">
+          <a:bodyPr wrap="square" lIns="0" tIns="0" rIns="0" bIns="0" rtlCol="0" anchor="t">
             <a:spAutoFit/>
           </a:bodyPr>
           <a:lstStyle/>
@@ -2195,7 +953,7 @@
           </a:prstGeom>
         </p:spPr>
         <p:txBody>
-          <a:bodyPr wrap="square" rtlCol="0" lIns="0" tIns="0" rIns="0" bIns="0" anchor="t">
+          <a:bodyPr wrap="square" lIns="0" tIns="0" rIns="0" bIns="0" rtlCol="0" anchor="t">
             <a:spAutoFit/>
           </a:bodyPr>
           <a:lstStyle/>
@@ -2243,7 +1001,7 @@
           </a:prstGeom>
         </p:spPr>
         <p:txBody>
-          <a:bodyPr wrap="square" rtlCol="0" lIns="0" tIns="0" rIns="0" bIns="0" anchor="t">
+          <a:bodyPr wrap="square" lIns="0" tIns="0" rIns="0" bIns="0" rtlCol="0" anchor="t">
             <a:spAutoFit/>
           </a:bodyPr>
           <a:lstStyle/>
@@ -2335,7 +1093,7 @@
           </a:prstGeom>
         </p:spPr>
         <p:txBody>
-          <a:bodyPr wrap="square" rtlCol="0" lIns="0" tIns="0" rIns="0" bIns="0" anchor="t">
+          <a:bodyPr wrap="square" lIns="0" tIns="0" rIns="0" bIns="0" rtlCol="0" anchor="t">
             <a:spAutoFit/>
           </a:bodyPr>
           <a:lstStyle/>
@@ -2416,7 +1174,7 @@
           </a:prstGeom>
         </p:spPr>
         <p:txBody>
-          <a:bodyPr wrap="square" rtlCol="0" lIns="0" tIns="0" rIns="0" bIns="0" anchor="t">
+          <a:bodyPr wrap="square" lIns="0" tIns="0" rIns="0" bIns="0" rtlCol="0" anchor="t">
             <a:spAutoFit/>
           </a:bodyPr>
           <a:lstStyle/>
@@ -2464,7 +1222,7 @@
           </a:prstGeom>
         </p:spPr>
         <p:txBody>
-          <a:bodyPr wrap="square" rtlCol="0" lIns="0" tIns="0" rIns="0" bIns="0" anchor="t">
+          <a:bodyPr wrap="square" lIns="0" tIns="0" rIns="0" bIns="0" rtlCol="0" anchor="t">
             <a:spAutoFit/>
           </a:bodyPr>
           <a:lstStyle/>
@@ -2512,7 +1270,7 @@
           </a:prstGeom>
         </p:spPr>
         <p:txBody>
-          <a:bodyPr wrap="square" rtlCol="0" lIns="0" tIns="0" rIns="0" bIns="0" anchor="t">
+          <a:bodyPr wrap="square" lIns="0" tIns="0" rIns="0" bIns="0" rtlCol="0" anchor="t">
             <a:spAutoFit/>
           </a:bodyPr>
           <a:lstStyle/>
@@ -2582,7 +1340,7 @@
           </a:prstGeom>
         </p:spPr>
         <p:txBody>
-          <a:bodyPr wrap="square" rtlCol="0" lIns="0" tIns="0" rIns="0" bIns="0" anchor="t">
+          <a:bodyPr wrap="square" lIns="0" tIns="0" rIns="0" bIns="0" rtlCol="0" anchor="t">
             <a:spAutoFit/>
           </a:bodyPr>
           <a:lstStyle/>
@@ -2630,7 +1388,7 @@
           </a:prstGeom>
         </p:spPr>
         <p:txBody>
-          <a:bodyPr wrap="square" rtlCol="0" lIns="0" tIns="0" rIns="0" bIns="0" anchor="t">
+          <a:bodyPr wrap="square" lIns="0" tIns="0" rIns="0" bIns="0" rtlCol="0" anchor="t">
             <a:spAutoFit/>
           </a:bodyPr>
           <a:lstStyle/>
@@ -2700,7 +1458,7 @@
           </a:prstGeom>
         </p:spPr>
         <p:txBody>
-          <a:bodyPr wrap="square" rtlCol="0" lIns="0" tIns="0" rIns="0" bIns="0" anchor="t">
+          <a:bodyPr wrap="square" lIns="0" tIns="0" rIns="0" bIns="0" rtlCol="0" anchor="t">
             <a:spAutoFit/>
           </a:bodyPr>
           <a:lstStyle/>
@@ -2781,7 +1539,7 @@
           </a:prstGeom>
         </p:spPr>
         <p:txBody>
-          <a:bodyPr wrap="square" rtlCol="0" lIns="0" tIns="0" rIns="0" bIns="0" anchor="t">
+          <a:bodyPr wrap="square" lIns="0" tIns="0" rIns="0" bIns="0" rtlCol="0" anchor="t">
             <a:spAutoFit/>
           </a:bodyPr>
           <a:lstStyle/>
@@ -2829,7 +1587,7 @@
           </a:prstGeom>
         </p:spPr>
         <p:txBody>
-          <a:bodyPr wrap="square" rtlCol="0" lIns="0" tIns="0" rIns="0" bIns="0" anchor="t">
+          <a:bodyPr wrap="square" lIns="0" tIns="0" rIns="0" bIns="0" rtlCol="0" anchor="t">
             <a:spAutoFit/>
           </a:bodyPr>
           <a:lstStyle/>
@@ -2877,7 +1635,7 @@
           </a:prstGeom>
         </p:spPr>
         <p:txBody>
-          <a:bodyPr wrap="square" rtlCol="0" lIns="0" tIns="0" rIns="0" bIns="0" anchor="t">
+          <a:bodyPr wrap="square" lIns="0" tIns="0" rIns="0" bIns="0" rtlCol="0" anchor="t">
             <a:spAutoFit/>
           </a:bodyPr>
           <a:lstStyle/>
@@ -2947,7 +1705,7 @@
           </a:prstGeom>
         </p:spPr>
         <p:txBody>
-          <a:bodyPr wrap="square" rtlCol="0" lIns="0" tIns="0" rIns="0" bIns="0" anchor="t">
+          <a:bodyPr wrap="square" lIns="0" tIns="0" rIns="0" bIns="0" rtlCol="0" anchor="t">
             <a:spAutoFit/>
           </a:bodyPr>
           <a:lstStyle/>
@@ -2995,7 +1753,7 @@
           </a:prstGeom>
         </p:spPr>
         <p:txBody>
-          <a:bodyPr wrap="square" rtlCol="0" lIns="0" tIns="0" rIns="0" bIns="0" anchor="t">
+          <a:bodyPr wrap="square" lIns="0" tIns="0" rIns="0" bIns="0" rtlCol="0" anchor="t">
             <a:spAutoFit/>
           </a:bodyPr>
           <a:lstStyle/>
@@ -3065,7 +1823,7 @@
           </a:prstGeom>
         </p:spPr>
         <p:txBody>
-          <a:bodyPr wrap="square" rtlCol="0" lIns="0" tIns="0" rIns="0" bIns="0" anchor="t">
+          <a:bodyPr wrap="square" lIns="0" tIns="0" rIns="0" bIns="0" rtlCol="0" anchor="t">
             <a:spAutoFit/>
           </a:bodyPr>
           <a:lstStyle/>
@@ -3146,7 +1904,7 @@
           </a:prstGeom>
         </p:spPr>
         <p:txBody>
-          <a:bodyPr wrap="square" rtlCol="0" lIns="0" tIns="0" rIns="0" bIns="0" anchor="t">
+          <a:bodyPr wrap="square" lIns="0" tIns="0" rIns="0" bIns="0" rtlCol="0" anchor="t">
             <a:spAutoFit/>
           </a:bodyPr>
           <a:lstStyle/>
@@ -3194,7 +1952,7 @@
           </a:prstGeom>
         </p:spPr>
         <p:txBody>
-          <a:bodyPr wrap="square" rtlCol="0" lIns="0" tIns="0" rIns="0" bIns="0" anchor="t">
+          <a:bodyPr wrap="square" lIns="0" tIns="0" rIns="0" bIns="0" rtlCol="0" anchor="t">
             <a:spAutoFit/>
           </a:bodyPr>
           <a:lstStyle/>
@@ -3242,7 +2000,7 @@
           </a:prstGeom>
         </p:spPr>
         <p:txBody>
-          <a:bodyPr wrap="square" rtlCol="0" lIns="0" tIns="0" rIns="0" bIns="0" anchor="t">
+          <a:bodyPr wrap="square" lIns="0" tIns="0" rIns="0" bIns="0" rtlCol="0" anchor="t">
             <a:spAutoFit/>
           </a:bodyPr>
           <a:lstStyle/>
@@ -3323,7 +2081,7 @@
           </a:prstGeom>
         </p:spPr>
         <p:txBody>
-          <a:bodyPr wrap="square" rtlCol="0" lIns="0" tIns="0" rIns="0" bIns="0" anchor="t">
+          <a:bodyPr wrap="square" lIns="0" tIns="0" rIns="0" bIns="0" rtlCol="0" anchor="t">
             <a:spAutoFit/>
           </a:bodyPr>
           <a:lstStyle/>
@@ -3371,7 +2129,7 @@
           </a:prstGeom>
         </p:spPr>
         <p:txBody>
-          <a:bodyPr wrap="square" rtlCol="0" lIns="0" tIns="0" rIns="0" bIns="0" anchor="t">
+          <a:bodyPr wrap="square" lIns="0" tIns="0" rIns="0" bIns="0" rtlCol="0" anchor="t">
             <a:spAutoFit/>
           </a:bodyPr>
           <a:lstStyle/>
@@ -3463,7 +2221,7 @@
           </a:prstGeom>
         </p:spPr>
         <p:txBody>
-          <a:bodyPr wrap="square" rtlCol="0" lIns="0" tIns="0" rIns="0" bIns="0" anchor="t">
+          <a:bodyPr wrap="square" lIns="0" tIns="0" rIns="0" bIns="0" rtlCol="0" anchor="t">
             <a:spAutoFit/>
           </a:bodyPr>
           <a:lstStyle/>
@@ -3544,7 +2302,7 @@
           </a:prstGeom>
         </p:spPr>
         <p:txBody>
-          <a:bodyPr wrap="square" rtlCol="0" lIns="0" tIns="0" rIns="0" bIns="0" anchor="t">
+          <a:bodyPr wrap="square" lIns="0" tIns="0" rIns="0" bIns="0" rtlCol="0" anchor="t">
             <a:spAutoFit/>
           </a:bodyPr>
           <a:lstStyle/>
@@ -3592,7 +2350,7 @@
           </a:prstGeom>
         </p:spPr>
         <p:txBody>
-          <a:bodyPr wrap="square" rtlCol="0" lIns="0" tIns="0" rIns="0" bIns="0" anchor="t">
+          <a:bodyPr wrap="square" lIns="0" tIns="0" rIns="0" bIns="0" rtlCol="0" anchor="t">
             <a:spAutoFit/>
           </a:bodyPr>
           <a:lstStyle/>
@@ -3640,7 +2398,7 @@
           </a:prstGeom>
         </p:spPr>
         <p:txBody>
-          <a:bodyPr wrap="square" rtlCol="0" lIns="0" tIns="0" rIns="0" bIns="0" anchor="t">
+          <a:bodyPr wrap="square" lIns="0" tIns="0" rIns="0" bIns="0" rtlCol="0" anchor="t">
             <a:spAutoFit/>
           </a:bodyPr>
           <a:lstStyle/>
@@ -3721,7 +2479,7 @@
           </a:prstGeom>
         </p:spPr>
         <p:txBody>
-          <a:bodyPr wrap="square" rtlCol="0" lIns="0" tIns="0" rIns="0" bIns="0" anchor="t">
+          <a:bodyPr wrap="square" lIns="0" tIns="0" rIns="0" bIns="0" rtlCol="0" anchor="t">
             <a:spAutoFit/>
           </a:bodyPr>
           <a:lstStyle/>
@@ -3802,7 +2560,7 @@
           </a:prstGeom>
         </p:spPr>
         <p:txBody>
-          <a:bodyPr wrap="square" rtlCol="0" lIns="0" tIns="0" rIns="0" bIns="0" anchor="t">
+          <a:bodyPr wrap="square" lIns="0" tIns="0" rIns="0" bIns="0" rtlCol="0" anchor="t">
             <a:spAutoFit/>
           </a:bodyPr>
           <a:lstStyle/>
@@ -3850,7 +2608,7 @@
           </a:prstGeom>
         </p:spPr>
         <p:txBody>
-          <a:bodyPr wrap="square" rtlCol="0" lIns="0" tIns="0" rIns="0" bIns="0" anchor="t">
+          <a:bodyPr wrap="square" lIns="0" tIns="0" rIns="0" bIns="0" rtlCol="0" anchor="t">
             <a:spAutoFit/>
           </a:bodyPr>
           <a:lstStyle/>
@@ -3898,7 +2656,7 @@
           </a:prstGeom>
         </p:spPr>
         <p:txBody>
-          <a:bodyPr wrap="square" rtlCol="0" lIns="0" tIns="0" rIns="0" bIns="0" anchor="t">
+          <a:bodyPr wrap="square" lIns="0" tIns="0" rIns="0" bIns="0" rtlCol="0" anchor="t">
             <a:spAutoFit/>
           </a:bodyPr>
           <a:lstStyle/>
@@ -3990,7 +2748,7 @@
           </a:prstGeom>
         </p:spPr>
         <p:txBody>
-          <a:bodyPr wrap="square" rtlCol="0" lIns="0" tIns="0" rIns="0" bIns="0" anchor="t">
+          <a:bodyPr wrap="square" lIns="0" tIns="0" rIns="0" bIns="0" rtlCol="0" anchor="t">
             <a:spAutoFit/>
           </a:bodyPr>
           <a:lstStyle/>
@@ -4038,7 +2796,7 @@
           </a:prstGeom>
         </p:spPr>
         <p:txBody>
-          <a:bodyPr wrap="square" rtlCol="0" lIns="0" tIns="0" rIns="0" bIns="0" anchor="t">
+          <a:bodyPr wrap="square" lIns="0" tIns="0" rIns="0" bIns="0" rtlCol="0" anchor="t">
             <a:spAutoFit/>
           </a:bodyPr>
           <a:lstStyle/>
@@ -4119,7 +2877,7 @@
           </a:prstGeom>
         </p:spPr>
         <p:txBody>
-          <a:bodyPr wrap="square" rtlCol="0" lIns="0" tIns="0" rIns="0" bIns="0" anchor="t">
+          <a:bodyPr wrap="square" lIns="0" tIns="0" rIns="0" bIns="0" rtlCol="0" anchor="t">
             <a:spAutoFit/>
           </a:bodyPr>
           <a:lstStyle/>
@@ -4159,7 +2917,7 @@
     <p:bg>
       <p:bgPr>
         <a:solidFill>
-          <a:srgbClr val="F6F5F0"/>
+          <a:srgbClr val="152B3C"/>
         </a:solidFill>
         <a:effectLst/>
       </p:bgPr>
@@ -4183,7 +2941,7 @@
           <p:cNvPr id="3" name="TextBox 3">
             <a:extLst>
               <a:ext uri="{FF2B5EF4-FFF2-40B4-BE49-F238E27FC236}">
-                <a16:creationId xmlns:a16="http://schemas.microsoft.com/office/drawing/2014/main" id="{433C1197-4939-4CFA-9917-2996A467AF33}"/>
+                <a16:creationId xmlns:a16="http://schemas.microsoft.com/office/drawing/2014/main" id="{2999EDD3-0B8A-40E9-A1BD-83F15AFEB2F0}"/>
               </a:ext>
             </a:extLst>
           </p:cNvPr>
@@ -4200,7 +2958,7 @@
           </a:prstGeom>
         </p:spPr>
         <p:txBody>
-          <a:bodyPr wrap="square" rtlCol="0" lIns="0" tIns="0" rIns="0" bIns="0" anchor="t">
+          <a:bodyPr wrap="square" lIns="0" tIns="0" rIns="0" bIns="0" rtlCol="0" anchor="t">
             <a:spAutoFit/>
           </a:bodyPr>
           <a:lstStyle/>
@@ -4216,12 +2974,12 @@
             <a:r>
               <a:rPr sz="3400" b="1">
                 <a:solidFill>
-                  <a:srgbClr val="152B3C"/>
-                </a:solidFill>
-                <a:latin typeface="Hiragino Sans GB"/>
-                <a:ea typeface="Hiragino Sans GB"/>
-              </a:rPr>
-              <a:t>自测题：单选题</a:t>
+                  <a:srgbClr val="F6F5F0"/>
+                </a:solidFill>
+                <a:latin typeface="Hiragino Sans GB"/>
+                <a:ea typeface="Hiragino Sans GB"/>
+              </a:rPr>
+              <a:t>第九课完成情景总结</a:t>
             </a:r>
           </a:p>
         </p:txBody>
@@ -4231,45 +2989,45 @@
           <p:cNvPr id="4" name="TextBox 4">
             <a:extLst>
               <a:ext uri="{FF2B5EF4-FFF2-40B4-BE49-F238E27FC236}">
-                <a16:creationId xmlns:a16="http://schemas.microsoft.com/office/drawing/2014/main" id="{A8784FA7-3FE1-4F1A-8B46-4E2CC698A6A5}"/>
-              </a:ext>
-            </a:extLst>
-          </p:cNvPr>
-          <p:cNvSpPr txBox="1"/>
-          <p:nvPr/>
-        </p:nvSpPr>
-        <p:spPr>
-          <a:xfrm>
-            <a:off x="685800" y="1752600"/>
-            <a:ext cx="5095875" cy="514350"/>
-          </a:xfrm>
-          <a:prstGeom prst="rect">
-            <a:avLst/>
-          </a:prstGeom>
-        </p:spPr>
-        <p:txBody>
-          <a:bodyPr wrap="square" rtlCol="0" lIns="0" tIns="0" rIns="0" bIns="0" anchor="t">
-            <a:spAutoFit/>
-          </a:bodyPr>
-          <a:lstStyle/>
-          <a:p>
-            <a:pPr>
-              <a:lnSpc>
-                <a:spcPct val="115000"/>
-              </a:lnSpc>
-              <a:spcAft>
-                <a:spcPts val="0"/>
-              </a:spcAft>
-            </a:pPr>
-            <a:r>
-              <a:rPr sz="2500" b="1">
-                <a:solidFill>
-                  <a:srgbClr val="166A68"/>
-                </a:solidFill>
-                <a:latin typeface="Hiragino Sans GB"/>
-                <a:ea typeface="Hiragino Sans GB"/>
-              </a:rPr>
-              <a:t>01—02｜每题 5 分</a:t>
+                <a16:creationId xmlns:a16="http://schemas.microsoft.com/office/drawing/2014/main" id="{95CA5D89-313D-4A90-B08E-377997E37366}"/>
+              </a:ext>
+            </a:extLst>
+          </p:cNvPr>
+          <p:cNvSpPr txBox="1"/>
+          <p:nvPr/>
+        </p:nvSpPr>
+        <p:spPr>
+          <a:xfrm>
+            <a:off x="685800" y="1714500"/>
+            <a:ext cx="10668000" cy="714375"/>
+          </a:xfrm>
+          <a:prstGeom prst="rect">
+            <a:avLst/>
+          </a:prstGeom>
+        </p:spPr>
+        <p:txBody>
+          <a:bodyPr wrap="square" lIns="0" tIns="0" rIns="0" bIns="0" rtlCol="0" anchor="t">
+            <a:spAutoFit/>
+          </a:bodyPr>
+          <a:lstStyle/>
+          <a:p>
+            <a:pPr>
+              <a:lnSpc>
+                <a:spcPct val="115000"/>
+              </a:lnSpc>
+              <a:spcAft>
+                <a:spcPts val="0"/>
+              </a:spcAft>
+            </a:pPr>
+            <a:r>
+              <a:rPr sz="2700" b="1">
+                <a:solidFill>
+                  <a:srgbClr val="F6F5F0"/>
+                </a:solidFill>
+                <a:latin typeface="Hiragino Sans GB"/>
+                <a:ea typeface="Hiragino Sans GB"/>
+              </a:rPr>
+              <a:t>已完成设定</a:t>
             </a:r>
           </a:p>
         </p:txBody>
@@ -4279,101 +3037,79 @@
           <p:cNvPr id="5" name="TextBox 5">
             <a:extLst>
               <a:ext uri="{FF2B5EF4-FFF2-40B4-BE49-F238E27FC236}">
-                <a16:creationId xmlns:a16="http://schemas.microsoft.com/office/drawing/2014/main" id="{987C4F70-E727-4B73-929B-0218AA041588}"/>
-              </a:ext>
-            </a:extLst>
-          </p:cNvPr>
-          <p:cNvSpPr txBox="1"/>
-          <p:nvPr/>
-        </p:nvSpPr>
-        <p:spPr>
-          <a:xfrm>
-            <a:off x="685800" y="2524125"/>
-            <a:ext cx="5095875" cy="3286125"/>
-          </a:xfrm>
-          <a:prstGeom prst="rect">
-            <a:avLst/>
-          </a:prstGeom>
-        </p:spPr>
-        <p:txBody>
-          <a:bodyPr wrap="square" rtlCol="0" lIns="0" tIns="0" rIns="0" bIns="0" anchor="t">
-            <a:spAutoFit/>
-          </a:bodyPr>
-          <a:lstStyle/>
-          <a:p>
-            <a:pPr>
-              <a:lnSpc>
-                <a:spcPct val="115000"/>
-              </a:lnSpc>
-              <a:spcAft>
-                <a:spcPts val="0"/>
-              </a:spcAft>
-            </a:pPr>
-            <a:r>
-              <a:rPr sz="2100">
-                <a:solidFill>
-                  <a:srgbClr val="152B3C"/>
-                </a:solidFill>
-                <a:latin typeface="Hiragino Sans GB"/>
-                <a:ea typeface="Hiragino Sans GB"/>
-              </a:rPr>
-              <a:t>1. 结构化 JSON 的主要作用？</a:t>
-            </a:r>
-            <a:br/>
-            <a:r>
-              <a:rPr sz="2100">
-                <a:solidFill>
-                  <a:srgbClr val="152B3C"/>
-                </a:solidFill>
-                <a:latin typeface="Hiragino Sans GB"/>
-                <a:ea typeface="Hiragino Sans GB"/>
-              </a:rPr>
-              <a:t>A 美化文字　B 便于解析与渲染</a:t>
-            </a:r>
-            <a:br/>
-            <a:r>
-              <a:rPr sz="2100">
-                <a:solidFill>
-                  <a:srgbClr val="152B3C"/>
-                </a:solidFill>
-                <a:latin typeface="Hiragino Sans GB"/>
-                <a:ea typeface="Hiragino Sans GB"/>
-              </a:rPr>
-              <a:t>C 保证答案正确　D 免除校验</a:t>
-            </a:r>
-            <a:br/>
-            <a:br/>
-            <a:r>
-              <a:rPr sz="2100">
-                <a:solidFill>
-                  <a:srgbClr val="152B3C"/>
-                </a:solidFill>
-                <a:latin typeface="Hiragino Sans GB"/>
-                <a:ea typeface="Hiragino Sans GB"/>
-              </a:rPr>
-              <a:t>2. 新题生成时应如何处理？</a:t>
-            </a:r>
-            <a:br/>
-            <a:r>
-              <a:rPr sz="2100">
-                <a:solidFill>
-                  <a:srgbClr val="152B3C"/>
-                </a:solidFill>
-                <a:latin typeface="Hiragino Sans GB"/>
-                <a:ea typeface="Hiragino Sans GB"/>
-              </a:rPr>
-              <a:t>A 保留旧结果　B 只清题干</a:t>
-            </a:r>
-            <a:br/>
-            <a:r>
-              <a:rPr sz="2100">
-                <a:solidFill>
-                  <a:srgbClr val="152B3C"/>
-                </a:solidFill>
-                <a:latin typeface="Hiragino Sans GB"/>
-                <a:ea typeface="Hiragino Sans GB"/>
-              </a:rPr>
-              <a:t>C 清空旧答案与评分　D 自动交卷</a:t>
+                <a16:creationId xmlns:a16="http://schemas.microsoft.com/office/drawing/2014/main" id="{4F120496-3109-4A1F-A844-0915DC4D1BE7}"/>
+              </a:ext>
+            </a:extLst>
+          </p:cNvPr>
+          <p:cNvSpPr txBox="1"/>
+          <p:nvPr/>
+        </p:nvSpPr>
+        <p:spPr>
+          <a:xfrm>
+            <a:off x="685800" y="2714625"/>
+            <a:ext cx="10668000" cy="3095625"/>
+          </a:xfrm>
+          <a:prstGeom prst="rect">
+            <a:avLst/>
+          </a:prstGeom>
+        </p:spPr>
+        <p:txBody>
+          <a:bodyPr wrap="square" lIns="0" tIns="0" rIns="0" bIns="0" rtlCol="0" anchor="t">
+            <a:spAutoFit/>
+          </a:bodyPr>
+          <a:lstStyle/>
+          <a:p>
+            <a:pPr>
+              <a:lnSpc>
+                <a:spcPct val="115000"/>
+              </a:lnSpc>
+              <a:spcAft>
+                <a:spcPts val="0"/>
+              </a:spcAft>
+            </a:pPr>
+            <a:r>
+              <a:rPr sz="2300">
+                <a:solidFill>
+                  <a:srgbClr val="F6F5F0"/>
+                </a:solidFill>
+                <a:latin typeface="Hiragino Sans GB"/>
+                <a:ea typeface="Hiragino Sans GB"/>
+              </a:rPr>
+              <a:t>基础流程：选择难度、生成单选题、作答判分、错题复习。</a:t>
+            </a:r>
+            <a:br/>
+            <a:r>
+              <a:rPr sz="2300">
+                <a:solidFill>
+                  <a:srgbClr val="F6F5F0"/>
+                </a:solidFill>
+                <a:latin typeface="Hiragino Sans GB"/>
+                <a:ea typeface="Hiragino Sans GB"/>
+              </a:rPr>
+              <a:t>挑战流程：简答题生成、按答案要点评分、展示解释。</a:t>
+            </a:r>
+            <a:br/>
+            <a:br/>
+            <a:r>
+              <a:rPr sz="2300">
+                <a:solidFill>
+                  <a:srgbClr val="F6F5F0"/>
+                </a:solidFill>
+                <a:latin typeface="Hiragino Sans GB"/>
+                <a:ea typeface="Hiragino Sans GB"/>
+              </a:rPr>
+              <a:t>下一步自测：独立回答 8 题，再按同一量表复评。</a:t>
+            </a:r>
+            <a:br/>
+            <a:r>
+              <a:rPr sz="2300">
+                <a:solidFill>
+                  <a:srgbClr val="F6F5F0"/>
+                </a:solidFill>
+                <a:latin typeface="Hiragino Sans GB"/>
+                <a:ea typeface="Hiragino Sans GB"/>
+              </a:rPr>
+              <a:t>课程材料中的功能描述为假设完成状态，不作为实际实现或验收证明。</a:t>
             </a:r>
           </a:p>
         </p:txBody>
@@ -4383,159 +3119,7 @@
           <p:cNvPr id="6" name="TextBox 6">
             <a:extLst>
               <a:ext uri="{FF2B5EF4-FFF2-40B4-BE49-F238E27FC236}">
-                <a16:creationId xmlns:a16="http://schemas.microsoft.com/office/drawing/2014/main" id="{6CBF2861-1A83-49F7-907E-FDE138047D60}"/>
-              </a:ext>
-            </a:extLst>
-          </p:cNvPr>
-          <p:cNvSpPr txBox="1"/>
-          <p:nvPr/>
-        </p:nvSpPr>
-        <p:spPr>
-          <a:xfrm>
-            <a:off x="6438900" y="1752600"/>
-            <a:ext cx="5095875" cy="514350"/>
-          </a:xfrm>
-          <a:prstGeom prst="rect">
-            <a:avLst/>
-          </a:prstGeom>
-        </p:spPr>
-        <p:txBody>
-          <a:bodyPr wrap="square" rtlCol="0" lIns="0" tIns="0" rIns="0" bIns="0" anchor="t">
-            <a:spAutoFit/>
-          </a:bodyPr>
-          <a:lstStyle/>
-          <a:p>
-            <a:pPr>
-              <a:lnSpc>
-                <a:spcPct val="115000"/>
-              </a:lnSpc>
-              <a:spcAft>
-                <a:spcPts val="0"/>
-              </a:spcAft>
-            </a:pPr>
-            <a:r>
-              <a:rPr sz="2500" b="1">
-                <a:solidFill>
-                  <a:srgbClr val="166A68"/>
-                </a:solidFill>
-                <a:latin typeface="Hiragino Sans GB"/>
-                <a:ea typeface="Hiragino Sans GB"/>
-              </a:rPr>
-              <a:t>03—04｜每题 5 分</a:t>
-            </a:r>
-          </a:p>
-        </p:txBody>
-      </p:sp>
-      <p:sp>
-        <p:nvSpPr>
-          <p:cNvPr id="7" name="TextBox 7">
-            <a:extLst>
-              <a:ext uri="{FF2B5EF4-FFF2-40B4-BE49-F238E27FC236}">
-                <a16:creationId xmlns:a16="http://schemas.microsoft.com/office/drawing/2014/main" id="{60DC0C11-87A8-4CBE-ADF6-F46A267B058A}"/>
-              </a:ext>
-            </a:extLst>
-          </p:cNvPr>
-          <p:cNvSpPr txBox="1"/>
-          <p:nvPr/>
-        </p:nvSpPr>
-        <p:spPr>
-          <a:xfrm>
-            <a:off x="6438900" y="2524125"/>
-            <a:ext cx="5095875" cy="3286125"/>
-          </a:xfrm>
-          <a:prstGeom prst="rect">
-            <a:avLst/>
-          </a:prstGeom>
-        </p:spPr>
-        <p:txBody>
-          <a:bodyPr wrap="square" rtlCol="0" lIns="0" tIns="0" rIns="0" bIns="0" anchor="t">
-            <a:spAutoFit/>
-          </a:bodyPr>
-          <a:lstStyle/>
-          <a:p>
-            <a:pPr>
-              <a:lnSpc>
-                <a:spcPct val="115000"/>
-              </a:lnSpc>
-              <a:spcAft>
-                <a:spcPts val="0"/>
-              </a:spcAft>
-            </a:pPr>
-            <a:r>
-              <a:rPr sz="2100">
-                <a:solidFill>
-                  <a:srgbClr val="152B3C"/>
-                </a:solidFill>
-                <a:latin typeface="Hiragino Sans GB"/>
-                <a:ea typeface="Hiragino Sans GB"/>
-              </a:rPr>
-              <a:t>3. 单选题答错后的复习状态是？</a:t>
-            </a:r>
-            <a:br/>
-            <a:r>
-              <a:rPr sz="2100">
-                <a:solidFill>
-                  <a:srgbClr val="152B3C"/>
-                </a:solidFill>
-                <a:latin typeface="Hiragino Sans GB"/>
-                <a:ea typeface="Hiragino Sans GB"/>
-              </a:rPr>
-              <a:t>A mastered　B reviewList=true</a:t>
-            </a:r>
-            <a:br/>
-            <a:r>
-              <a:rPr sz="2100">
-                <a:solidFill>
-                  <a:srgbClr val="152B3C"/>
-                </a:solidFill>
-                <a:latin typeface="Hiragino Sans GB"/>
-                <a:ea typeface="Hiragino Sans GB"/>
-              </a:rPr>
-              <a:t>C 删除知识点　D 退出登录</a:t>
-            </a:r>
-            <a:br/>
-            <a:br/>
-            <a:r>
-              <a:rPr sz="2100">
-                <a:solidFill>
-                  <a:srgbClr val="152B3C"/>
-                </a:solidFill>
-                <a:latin typeface="Hiragino Sans GB"/>
-                <a:ea typeface="Hiragino Sans GB"/>
-              </a:rPr>
-              <a:t>4. 简答题 AI 评分的依据是？</a:t>
-            </a:r>
-            <a:br/>
-            <a:r>
-              <a:rPr sz="2100">
-                <a:solidFill>
-                  <a:srgbClr val="152B3C"/>
-                </a:solidFill>
-                <a:latin typeface="Hiragino Sans GB"/>
-                <a:ea typeface="Hiragino Sans GB"/>
-              </a:rPr>
-              <a:t>A 字数　B 与参考答案逐字一致</a:t>
-            </a:r>
-            <a:br/>
-            <a:r>
-              <a:rPr sz="2100">
-                <a:solidFill>
-                  <a:srgbClr val="152B3C"/>
-                </a:solidFill>
-                <a:latin typeface="Hiragino Sans GB"/>
-                <a:ea typeface="Hiragino Sans GB"/>
-              </a:rPr>
-              <a:t>C 语气　D 题目、要点及学生回答</a:t>
-            </a:r>
-          </a:p>
-        </p:txBody>
-      </p:sp>
-      <p:sp>
-        <p:nvSpPr>
-          <p:cNvPr id="8" name="TextBox 8">
-            <a:extLst>
-              <a:ext uri="{FF2B5EF4-FFF2-40B4-BE49-F238E27FC236}">
-                <a16:creationId xmlns:a16="http://schemas.microsoft.com/office/drawing/2014/main" id="{FFB8F47E-BDA7-491C-BC1B-76E825C8C79A}"/>
+                <a16:creationId xmlns:a16="http://schemas.microsoft.com/office/drawing/2014/main" id="{03A03BA2-470F-40DD-9FD0-E983EB1797E9}"/>
               </a:ext>
             </a:extLst>
           </p:cNvPr>
@@ -4552,7 +3136,7 @@
           </a:prstGeom>
         </p:spPr>
         <p:txBody>
-          <a:bodyPr wrap="square" rtlCol="0" lIns="0" tIns="0" rIns="0" bIns="0" anchor="t">
+          <a:bodyPr wrap="square" lIns="0" tIns="0" rIns="0" bIns="0" rtlCol="0" anchor="t">
             <a:spAutoFit/>
           </a:bodyPr>
           <a:lstStyle/>
@@ -4568,12 +3152,12 @@
             <a:r>
               <a:rPr sz="1200">
                 <a:solidFill>
-                  <a:srgbClr val="667885"/>
-                </a:solidFill>
-                <a:latin typeface="Hiragino Sans GB"/>
-                <a:ea typeface="Hiragino Sans GB"/>
-              </a:rPr>
-              <a:t>09 / 13</a:t>
+                  <a:srgbClr val="F6F5F0"/>
+                </a:solidFill>
+                <a:latin typeface="Hiragino Sans GB"/>
+                <a:ea typeface="Hiragino Sans GB"/>
+              </a:rPr>
+              <a:t>13 / 13</a:t>
             </a:r>
           </a:p>
         </p:txBody>
@@ -4700,5 +3284,7 @@
       </a:bgFillStyleLst>
     </a:fmtScheme>
   </a:themeElements>
+  <a:objectDefaults/>
+  <a:extraClrSchemeLst/>
 </a:theme>
 </file>
</xml_diff>